<commit_message>
Agrega evaluacion GiantSteps (20 temas, corrida Colab) a README, informe y presentacion
- Resultados por tema en experimentos/resultados/giantsteps.csv y .json: CNN 2/20 (MIREX 0,13), K-S 9/20 (MIREX 0,59 recalculado; el notebook imprime 0,54 por argumentos invertidos)
- Informe: nueva seccion 7.1 GiantSteps, audios de control aclarados como generados, Pappo con valores de Colab (A maj, 0,245), entornos local y Colab separados; PDF regenerado
- Presentacion: slide nueva de GiantSteps y fila en la tabla de resultados
- run_experimentos.py: mirex(verdad, prediccion) en el orden correcto
</commit_message>
<xml_diff>
--- a/presentacion/presentacion.pptx
+++ b/presentacion/presentacion.pptx
@@ -18,6 +18,7 @@
     <p:sldId id="266" r:id="rId17"/>
     <p:sldId id="267" r:id="rId18"/>
     <p:sldId id="268" r:id="rId19"/>
+    <p:sldId id="269" r:id="rId20"/>
   </p:sldIdLst>
   <p:sldSz cx="12193200" cy="6858000" type="screen4x3"/>
   <p:notesSz cx="6858000" cy="9144000"/>
@@ -3386,7 +3387,7 @@
     <p:bg>
       <p:bgPr>
         <a:solidFill>
-          <a:srgbClr val="F4F7FB"/>
+          <a:srgbClr val="FFFFFF"/>
         </a:solidFill>
         <a:effectLst/>
       </p:bgPr>
@@ -3446,7 +3447,7 @@
                 </a:solidFill>
                 <a:latin typeface="Calibri"/>
               </a:rPr>
-              <a:t>La causa: shortcut learning</a:t>
+              <a:t>Diagnóstico</a:t>
             </a:r>
           </a:p>
         </p:txBody>
@@ -3485,7 +3486,7 @@
                 </a:solidFill>
                 <a:latin typeface="Calibri"/>
               </a:rPr>
-              <a:t>No fue la arquitectura. Fue el conjunto de datos.</a:t>
+              <a:t>¿Qué sigue la red: la tonalidad o la frecuencia absoluta?</a:t>
             </a:r>
           </a:p>
         </p:txBody>
@@ -3529,16 +3530,40 @@
           </a:p>
         </p:txBody>
       </p:sp>
-      <p:sp>
-        <p:nvSpPr>
-          <p:cNvPr id="5" name="TextBox 4"/>
+      <p:pic>
+        <p:nvPicPr>
+          <p:cNvPr id="5" name="Picture 4" descr="diagnostico_octava.png"/>
+          <p:cNvPicPr>
+            <a:picLocks noChangeAspect="1"/>
+          </p:cNvPicPr>
+          <p:nvPr/>
+        </p:nvPicPr>
+        <p:blipFill>
+          <a:blip r:embed="rId2"/>
+          <a:stretch>
+            <a:fillRect/>
+          </a:stretch>
+        </p:blipFill>
+        <p:spPr>
+          <a:xfrm>
+            <a:off x="2496600" y="1368000"/>
+            <a:ext cx="7200000" cy="3600000"/>
+          </a:xfrm>
+          <a:prstGeom prst="rect">
+            <a:avLst/>
+          </a:prstGeom>
+        </p:spPr>
+      </p:pic>
+      <p:sp>
+        <p:nvSpPr>
+          <p:cNvPr id="6" name="TextBox 5"/>
           <p:cNvSpPr txBox="1"/>
           <p:nvPr/>
         </p:nvSpPr>
         <p:spPr>
           <a:xfrm>
-            <a:off x="648000" y="1655999"/>
-            <a:ext cx="10800000" cy="3240000"/>
+            <a:off x="720000" y="5184000"/>
+            <a:ext cx="10753200" cy="1296000"/>
           </a:xfrm>
           <a:prstGeom prst="rect">
             <a:avLst/>
@@ -3546,162 +3571,6 @@
           <a:noFill/>
         </p:spPr>
         <p:txBody>
-          <a:bodyPr wrap="square">
-            <a:spAutoFit/>
-          </a:bodyPr>
-          <a:lstStyle/>
-          <a:p>
-            <a:pPr>
-              <a:lnSpc>
-                <a:spcPct val="115000"/>
-              </a:lnSpc>
-              <a:spcAft>
-                <a:spcPts val="1100"/>
-              </a:spcAft>
-            </a:pPr>
-            <a:r>
-              <a:rPr sz="1750" b="1">
-                <a:solidFill>
-                  <a:srgbClr val="1F3864"/>
-                </a:solidFill>
-                <a:latin typeface="Calibri"/>
-              </a:rPr>
-              <a:t>•  El generador ubicaba cada tonalidad SIEMPRE en la misma octava.</a:t>
-            </a:r>
-          </a:p>
-          <a:p>
-            <a:pPr>
-              <a:lnSpc>
-                <a:spcPct val="115000"/>
-              </a:lnSpc>
-              <a:spcAft>
-                <a:spcPts val="1100"/>
-              </a:spcAft>
-            </a:pPr>
-            <a:r>
-              <a:rPr sz="1750" b="0">
-                <a:solidFill>
-                  <a:srgbClr val="444444"/>
-                </a:solidFill>
-                <a:latin typeface="Calibri"/>
-              </a:rPr>
-              <a:t>•  Dentro del dataset, "tonalidad" y "banda de frecuencias absolutas" eran predictores equivalentes.</a:t>
-            </a:r>
-          </a:p>
-          <a:p>
-            <a:pPr>
-              <a:lnSpc>
-                <a:spcPct val="115000"/>
-              </a:lnSpc>
-              <a:spcAft>
-                <a:spcPts val="1100"/>
-              </a:spcAft>
-            </a:pPr>
-            <a:r>
-              <a:rPr sz="1750" b="1">
-                <a:solidFill>
-                  <a:srgbClr val="1F3864"/>
-                </a:solidFill>
-                <a:latin typeface="Calibri"/>
-              </a:rPr>
-              <a:t>•  Ante dos soluciones equivalentes, el gradiente tomó la más fácil: detectar altura absoluta.</a:t>
-            </a:r>
-          </a:p>
-          <a:p>
-            <a:pPr>
-              <a:lnSpc>
-                <a:spcPct val="115000"/>
-              </a:lnSpc>
-              <a:spcAft>
-                <a:spcPts val="1100"/>
-              </a:spcAft>
-            </a:pPr>
-            <a:r>
-              <a:rPr sz="1750" b="0">
-                <a:solidFill>
-                  <a:srgbClr val="444444"/>
-                </a:solidFill>
-                <a:latin typeface="Calibri"/>
-              </a:rPr>
-              <a:t>•  Nunca necesitó construir relaciones intervalares, que es lo que define una tonalidad.</a:t>
-            </a:r>
-          </a:p>
-          <a:p>
-            <a:pPr>
-              <a:lnSpc>
-                <a:spcPct val="115000"/>
-              </a:lnSpc>
-              <a:spcAft>
-                <a:spcPts val="1100"/>
-              </a:spcAft>
-            </a:pPr>
-            <a:r>
-              <a:rPr sz="1750" b="1">
-                <a:solidFill>
-                  <a:srgbClr val="1F3864"/>
-                </a:solidFill>
-                <a:latin typeface="Calibri"/>
-              </a:rPr>
-              <a:t>•  El test, generado con el mismo sesgo, no podía detectarlo.</a:t>
-            </a:r>
-          </a:p>
-          <a:p>
-            <a:pPr>
-              <a:lnSpc>
-                <a:spcPct val="115000"/>
-              </a:lnSpc>
-              <a:spcAft>
-                <a:spcPts val="1100"/>
-              </a:spcAft>
-            </a:pPr>
-            <a:r>
-              <a:rPr sz="1750" b="0">
-                <a:solidFill>
-                  <a:srgbClr val="444444"/>
-                </a:solidFill>
-                <a:latin typeface="Calibri"/>
-              </a:rPr>
-              <a:t>•  Una CNN 1D sobre onda cruda es equivariante en tiempo, pero NO en frecuencia.</a:t>
-            </a:r>
-          </a:p>
-          <a:p>
-            <a:pPr>
-              <a:lnSpc>
-                <a:spcPct val="115000"/>
-              </a:lnSpc>
-              <a:spcAft>
-                <a:spcPts val="1100"/>
-              </a:spcAft>
-            </a:pPr>
-            <a:r>
-              <a:rPr sz="1750" b="0">
-                <a:solidFill>
-                  <a:srgbClr val="444444"/>
-                </a:solidFill>
-                <a:latin typeface="Calibri"/>
-              </a:rPr>
-              <a:t>•  El cromagrama sí es invariante a la octava por construcción: su sesgo inductivo es el correcto.</a:t>
-            </a:r>
-          </a:p>
-        </p:txBody>
-      </p:sp>
-      <p:sp>
-        <p:nvSpPr>
-          <p:cNvPr id="6" name="TextBox 5"/>
-          <p:cNvSpPr txBox="1"/>
-          <p:nvPr/>
-        </p:nvSpPr>
-        <p:spPr>
-          <a:xfrm>
-            <a:off x="900000" y="5256000"/>
-            <a:ext cx="10393200" cy="864000"/>
-          </a:xfrm>
-          <a:prstGeom prst="rect">
-            <a:avLst/>
-          </a:prstGeom>
-          <a:noFill/>
-        </p:spPr>
-        <p:txBody>
           <a:bodyPr wrap="square" anchor="t">
             <a:spAutoFit/>
           </a:bodyPr>
@@ -3709,17 +3578,33 @@
           <a:p>
             <a:pPr algn="ctr">
               <a:lnSpc>
-                <a:spcPct val="118000"/>
-              </a:lnSpc>
-            </a:pPr>
-            <a:r>
-              <a:rPr sz="2600" b="1">
+                <a:spcPct val="130000"/>
+              </a:lnSpc>
+            </a:pPr>
+            <a:r>
+              <a:rPr sz="2000" b="1">
                 <a:solidFill>
                   <a:srgbClr val="C0392B"/>
                 </a:solidFill>
                 <a:latin typeface="Calibri"/>
               </a:rPr>
-              <a:t>La red aprendió a detectar altura absoluta, no tonalidad.</a:t>
+              <a:t>Al desplazar el audio UN SEMITONO:</a:t>
+            </a:r>
+          </a:p>
+          <a:p>
+            <a:pPr algn="ctr">
+              <a:lnSpc>
+                <a:spcPct val="130000"/>
+              </a:lnSpc>
+            </a:pPr>
+            <a:r>
+              <a:rPr sz="2000" b="1">
+                <a:solidFill>
+                  <a:srgbClr val="C0392B"/>
+                </a:solidFill>
+                <a:latin typeface="Calibri"/>
+              </a:rPr>
+              <a:t>predice la etiqueta transpuesta el 91,7 %  ·  acierta la correcta el 0 %</a:t>
             </a:r>
           </a:p>
         </p:txBody>
@@ -3738,7 +3623,7 @@
     <p:bg>
       <p:bgPr>
         <a:solidFill>
-          <a:srgbClr val="FFFFFF"/>
+          <a:srgbClr val="F4F7FB"/>
         </a:solidFill>
         <a:effectLst/>
       </p:bgPr>
@@ -3798,7 +3683,7 @@
                 </a:solidFill>
                 <a:latin typeface="Calibri"/>
               </a:rPr>
-              <a:t>Conclusiones</a:t>
+              <a:t>La causa: shortcut learning</a:t>
             </a:r>
           </a:p>
         </p:txBody>
@@ -3837,7 +3722,7 @@
                 </a:solidFill>
                 <a:latin typeface="Calibri"/>
               </a:rPr>
-              <a:t>Qué me llevo de este trabajo</a:t>
+              <a:t>No fue la arquitectura. Fue el conjunto de datos.</a:t>
             </a:r>
           </a:p>
         </p:txBody>
@@ -3889,8 +3774,8 @@
         </p:nvSpPr>
         <p:spPr>
           <a:xfrm>
-            <a:off x="648000" y="1620000"/>
-            <a:ext cx="10800000" cy="3960000"/>
+            <a:off x="648000" y="1655999"/>
+            <a:ext cx="10800000" cy="3240000"/>
           </a:xfrm>
           <a:prstGeom prst="rect">
             <a:avLst/>
@@ -3908,17 +3793,17 @@
                 <a:spcPct val="115000"/>
               </a:lnSpc>
               <a:spcAft>
-                <a:spcPts val="900"/>
+                <a:spcPts val="1100"/>
               </a:spcAft>
             </a:pPr>
             <a:r>
-              <a:rPr sz="1700" b="1">
+              <a:rPr sz="1750" b="1">
                 <a:solidFill>
                   <a:srgbClr val="1F3864"/>
                 </a:solidFill>
                 <a:latin typeface="Calibri"/>
               </a:rPr>
-              <a:t>•  Con este diseño, la red NO superó a la línea de base. Esa es la respuesta honesta.</a:t>
+              <a:t>•  El generador ubicaba cada tonalidad SIEMPRE en la misma octava.</a:t>
             </a:r>
           </a:p>
           <a:p>
@@ -3927,17 +3812,17 @@
                 <a:spcPct val="115000"/>
               </a:lnSpc>
               <a:spcAft>
-                <a:spcPts val="900"/>
+                <a:spcPts val="1100"/>
               </a:spcAft>
             </a:pPr>
             <a:r>
-              <a:rPr sz="1700" b="0">
+              <a:rPr sz="1750" b="0">
                 <a:solidFill>
                   <a:srgbClr val="444444"/>
                 </a:solidFill>
                 <a:latin typeface="Calibri"/>
               </a:rPr>
-              <a:t>•  Una métrica de test perfecta no es evidencia de aprendizaje: fue el síntoma del problema.</a:t>
+              <a:t>•  Dentro del dataset, "tonalidad" y "banda de frecuencias absolutas" eran predictores equivalentes.</a:t>
             </a:r>
           </a:p>
           <a:p>
@@ -3946,17 +3831,17 @@
                 <a:spcPct val="115000"/>
               </a:lnSpc>
               <a:spcAft>
-                <a:spcPts val="900"/>
+                <a:spcPts val="1100"/>
               </a:spcAft>
             </a:pPr>
             <a:r>
-              <a:rPr sz="1700" b="1">
+              <a:rPr sz="1750" b="1">
                 <a:solidFill>
                   <a:srgbClr val="1F3864"/>
                 </a:solidFill>
                 <a:latin typeface="Calibri"/>
               </a:rPr>
-              <a:t>•  La línea de base no es un trámite del informe: fue el instrumento de diagnóstico.</a:t>
+              <a:t>•  Ante dos soluciones equivalentes, el gradiente tomó la más fácil: detectar altura absoluta.</a:t>
             </a:r>
           </a:p>
           <a:p>
@@ -3965,17 +3850,17 @@
                 <a:spcPct val="115000"/>
               </a:lnSpc>
               <a:spcAft>
-                <a:spcPts val="900"/>
+                <a:spcPts val="1100"/>
               </a:spcAft>
             </a:pPr>
             <a:r>
-              <a:rPr sz="1700" b="0">
+              <a:rPr sz="1750" b="0">
                 <a:solidFill>
                   <a:srgbClr val="444444"/>
                 </a:solidFill>
                 <a:latin typeface="Calibri"/>
               </a:rPr>
-              <a:t>•  Sin ese empate en 100 %, el trabajo habría reportado un éxito inexistente.</a:t>
+              <a:t>•  Nunca necesitó construir relaciones intervalares, que es lo que define una tonalidad.</a:t>
             </a:r>
           </a:p>
           <a:p>
@@ -3984,17 +3869,17 @@
                 <a:spcPct val="115000"/>
               </a:lnSpc>
               <a:spcAft>
-                <a:spcPts val="900"/>
+                <a:spcPts val="1100"/>
               </a:spcAft>
             </a:pPr>
             <a:r>
-              <a:rPr sz="1700" b="1">
+              <a:rPr sz="1750" b="1">
                 <a:solidFill>
                   <a:srgbClr val="1F3864"/>
                 </a:solidFill>
                 <a:latin typeface="Calibri"/>
               </a:rPr>
-              <a:t>•  Un test generado por el mismo generador que el train no mide generalización.</a:t>
+              <a:t>•  El test, generado con el mismo sesgo, no podía detectarlo.</a:t>
             </a:r>
           </a:p>
           <a:p>
@@ -4003,17 +3888,17 @@
                 <a:spcPct val="115000"/>
               </a:lnSpc>
               <a:spcAft>
-                <a:spcPts val="900"/>
+                <a:spcPts val="1100"/>
               </a:spcAft>
             </a:pPr>
             <a:r>
-              <a:rPr sz="1700" b="0">
+              <a:rPr sz="1750" b="0">
                 <a:solidFill>
                   <a:srgbClr val="444444"/>
                 </a:solidFill>
                 <a:latin typeface="Calibri"/>
               </a:rPr>
-              <a:t>•  Mide consistencia del generador. Detectar atajos exige evaluar fuera de distribución.</a:t>
+              <a:t>•  Una CNN 1D sobre onda cruda es equivariante en tiempo, pero NO en frecuencia.</a:t>
             </a:r>
           </a:p>
           <a:p>
@@ -4022,36 +3907,56 @@
                 <a:spcPct val="115000"/>
               </a:lnSpc>
               <a:spcAft>
-                <a:spcPts val="900"/>
+                <a:spcPts val="1100"/>
               </a:spcAft>
             </a:pPr>
             <a:r>
-              <a:rPr sz="1700" b="1">
-                <a:solidFill>
-                  <a:srgbClr val="1F3864"/>
-                </a:solidFill>
-                <a:latin typeface="Calibri"/>
-              </a:rPr>
-              <a:t>•  El sesgo inductivo era analizable antes de entrenar.</a:t>
-            </a:r>
-          </a:p>
-          <a:p>
-            <a:pPr>
-              <a:lnSpc>
-                <a:spcPct val="115000"/>
-              </a:lnSpc>
-              <a:spcAft>
-                <a:spcPts val="900"/>
-              </a:spcAft>
-            </a:pPr>
-            <a:r>
-              <a:rPr sz="1700" b="0">
+              <a:rPr sz="1750" b="0">
                 <a:solidFill>
                   <a:srgbClr val="444444"/>
                 </a:solidFill>
                 <a:latin typeface="Calibri"/>
               </a:rPr>
-              <a:t>•  El fallo estaba predicho por la arquitectura: faltaba invariancia a transposición.</a:t>
+              <a:t>•  El cromagrama sí es invariante a la octava por construcción: su sesgo inductivo es el correcto.</a:t>
+            </a:r>
+          </a:p>
+        </p:txBody>
+      </p:sp>
+      <p:sp>
+        <p:nvSpPr>
+          <p:cNvPr id="6" name="TextBox 5"/>
+          <p:cNvSpPr txBox="1"/>
+          <p:nvPr/>
+        </p:nvSpPr>
+        <p:spPr>
+          <a:xfrm>
+            <a:off x="900000" y="5256000"/>
+            <a:ext cx="10393200" cy="864000"/>
+          </a:xfrm>
+          <a:prstGeom prst="rect">
+            <a:avLst/>
+          </a:prstGeom>
+          <a:noFill/>
+        </p:spPr>
+        <p:txBody>
+          <a:bodyPr wrap="square" anchor="t">
+            <a:spAutoFit/>
+          </a:bodyPr>
+          <a:lstStyle/>
+          <a:p>
+            <a:pPr algn="ctr">
+              <a:lnSpc>
+                <a:spcPct val="118000"/>
+              </a:lnSpc>
+            </a:pPr>
+            <a:r>
+              <a:rPr sz="2600" b="1">
+                <a:solidFill>
+                  <a:srgbClr val="C0392B"/>
+                </a:solidFill>
+                <a:latin typeface="Calibri"/>
+              </a:rPr>
+              <a:t>La red aprendió a detectar altura absoluta, no tonalidad.</a:t>
             </a:r>
           </a:p>
         </p:txBody>
@@ -4070,7 +3975,7 @@
     <p:bg>
       <p:bgPr>
         <a:solidFill>
-          <a:srgbClr val="F4F7FB"/>
+          <a:srgbClr val="FFFFFF"/>
         </a:solidFill>
         <a:effectLst/>
       </p:bgPr>
@@ -4130,7 +4035,7 @@
                 </a:solidFill>
                 <a:latin typeface="Calibri"/>
               </a:rPr>
-              <a:t>Cómo se arregla</a:t>
+              <a:t>Conclusiones</a:t>
             </a:r>
           </a:p>
         </p:txBody>
@@ -4169,7 +4074,7 @@
                 </a:solidFill>
                 <a:latin typeface="Calibri"/>
               </a:rPr>
-              <a:t>Las correcciones salen directamente del diagnóstico</a:t>
+              <a:t>Qué me llevo de este trabajo</a:t>
             </a:r>
           </a:p>
         </p:txBody>
@@ -4209,6 +4114,338 @@
                 <a:latin typeface="Calibri"/>
               </a:rPr>
               <a:t>12</a:t>
+            </a:r>
+          </a:p>
+        </p:txBody>
+      </p:sp>
+      <p:sp>
+        <p:nvSpPr>
+          <p:cNvPr id="5" name="TextBox 4"/>
+          <p:cNvSpPr txBox="1"/>
+          <p:nvPr/>
+        </p:nvSpPr>
+        <p:spPr>
+          <a:xfrm>
+            <a:off x="648000" y="1620000"/>
+            <a:ext cx="10800000" cy="3960000"/>
+          </a:xfrm>
+          <a:prstGeom prst="rect">
+            <a:avLst/>
+          </a:prstGeom>
+          <a:noFill/>
+        </p:spPr>
+        <p:txBody>
+          <a:bodyPr wrap="square">
+            <a:spAutoFit/>
+          </a:bodyPr>
+          <a:lstStyle/>
+          <a:p>
+            <a:pPr>
+              <a:lnSpc>
+                <a:spcPct val="115000"/>
+              </a:lnSpc>
+              <a:spcAft>
+                <a:spcPts val="900"/>
+              </a:spcAft>
+            </a:pPr>
+            <a:r>
+              <a:rPr sz="1700" b="1">
+                <a:solidFill>
+                  <a:srgbClr val="1F3864"/>
+                </a:solidFill>
+                <a:latin typeface="Calibri"/>
+              </a:rPr>
+              <a:t>•  Con este diseño, la red NO superó a la línea de base. Esa es la respuesta honesta.</a:t>
+            </a:r>
+          </a:p>
+          <a:p>
+            <a:pPr>
+              <a:lnSpc>
+                <a:spcPct val="115000"/>
+              </a:lnSpc>
+              <a:spcAft>
+                <a:spcPts val="900"/>
+              </a:spcAft>
+            </a:pPr>
+            <a:r>
+              <a:rPr sz="1700" b="0">
+                <a:solidFill>
+                  <a:srgbClr val="444444"/>
+                </a:solidFill>
+                <a:latin typeface="Calibri"/>
+              </a:rPr>
+              <a:t>•  Una métrica de test perfecta no es evidencia de aprendizaje: fue el síntoma del problema.</a:t>
+            </a:r>
+          </a:p>
+          <a:p>
+            <a:pPr>
+              <a:lnSpc>
+                <a:spcPct val="115000"/>
+              </a:lnSpc>
+              <a:spcAft>
+                <a:spcPts val="900"/>
+              </a:spcAft>
+            </a:pPr>
+            <a:r>
+              <a:rPr sz="1700" b="1">
+                <a:solidFill>
+                  <a:srgbClr val="1F3864"/>
+                </a:solidFill>
+                <a:latin typeface="Calibri"/>
+              </a:rPr>
+              <a:t>•  La línea de base no es un trámite del informe: fue el instrumento de diagnóstico.</a:t>
+            </a:r>
+          </a:p>
+          <a:p>
+            <a:pPr>
+              <a:lnSpc>
+                <a:spcPct val="115000"/>
+              </a:lnSpc>
+              <a:spcAft>
+                <a:spcPts val="900"/>
+              </a:spcAft>
+            </a:pPr>
+            <a:r>
+              <a:rPr sz="1700" b="0">
+                <a:solidFill>
+                  <a:srgbClr val="444444"/>
+                </a:solidFill>
+                <a:latin typeface="Calibri"/>
+              </a:rPr>
+              <a:t>•  Sin ese empate en 100 %, el trabajo habría reportado un éxito inexistente.</a:t>
+            </a:r>
+          </a:p>
+          <a:p>
+            <a:pPr>
+              <a:lnSpc>
+                <a:spcPct val="115000"/>
+              </a:lnSpc>
+              <a:spcAft>
+                <a:spcPts val="900"/>
+              </a:spcAft>
+            </a:pPr>
+            <a:r>
+              <a:rPr sz="1700" b="1">
+                <a:solidFill>
+                  <a:srgbClr val="1F3864"/>
+                </a:solidFill>
+                <a:latin typeface="Calibri"/>
+              </a:rPr>
+              <a:t>•  Un test generado por el mismo generador que el train no mide generalización.</a:t>
+            </a:r>
+          </a:p>
+          <a:p>
+            <a:pPr>
+              <a:lnSpc>
+                <a:spcPct val="115000"/>
+              </a:lnSpc>
+              <a:spcAft>
+                <a:spcPts val="900"/>
+              </a:spcAft>
+            </a:pPr>
+            <a:r>
+              <a:rPr sz="1700" b="0">
+                <a:solidFill>
+                  <a:srgbClr val="444444"/>
+                </a:solidFill>
+                <a:latin typeface="Calibri"/>
+              </a:rPr>
+              <a:t>•  Mide consistencia del generador. Detectar atajos exige evaluar fuera de distribución.</a:t>
+            </a:r>
+          </a:p>
+          <a:p>
+            <a:pPr>
+              <a:lnSpc>
+                <a:spcPct val="115000"/>
+              </a:lnSpc>
+              <a:spcAft>
+                <a:spcPts val="900"/>
+              </a:spcAft>
+            </a:pPr>
+            <a:r>
+              <a:rPr sz="1700" b="1">
+                <a:solidFill>
+                  <a:srgbClr val="1F3864"/>
+                </a:solidFill>
+                <a:latin typeface="Calibri"/>
+              </a:rPr>
+              <a:t>•  El sesgo inductivo era analizable antes de entrenar.</a:t>
+            </a:r>
+          </a:p>
+          <a:p>
+            <a:pPr>
+              <a:lnSpc>
+                <a:spcPct val="115000"/>
+              </a:lnSpc>
+              <a:spcAft>
+                <a:spcPts val="900"/>
+              </a:spcAft>
+            </a:pPr>
+            <a:r>
+              <a:rPr sz="1700" b="0">
+                <a:solidFill>
+                  <a:srgbClr val="444444"/>
+                </a:solidFill>
+                <a:latin typeface="Calibri"/>
+              </a:rPr>
+              <a:t>•  El fallo estaba predicho por la arquitectura: faltaba invariancia a transposición.</a:t>
+            </a:r>
+          </a:p>
+        </p:txBody>
+      </p:sp>
+    </p:spTree>
+  </p:cSld>
+  <p:clrMapOvr>
+    <a:masterClrMapping/>
+  </p:clrMapOvr>
+</p:sld>
+</file>
+
+<file path=ppt/slides/slide13.xml><?xml version="1.0" encoding="utf-8"?>
+<p:sld xmlns:a="http://schemas.openxmlformats.org/drawingml/2006/main" xmlns:p="http://schemas.openxmlformats.org/presentationml/2006/main" xmlns:r="http://schemas.openxmlformats.org/officeDocument/2006/relationships">
+  <p:cSld>
+    <p:bg>
+      <p:bgPr>
+        <a:solidFill>
+          <a:srgbClr val="F4F7FB"/>
+        </a:solidFill>
+        <a:effectLst/>
+      </p:bgPr>
+    </p:bg>
+    <p:spTree>
+      <p:nvGrpSpPr>
+        <p:cNvPr id="1" name=""/>
+        <p:cNvGrpSpPr/>
+        <p:nvPr/>
+      </p:nvGrpSpPr>
+      <p:grpSpPr/>
+      <p:sp>
+        <p:nvSpPr>
+          <p:cNvPr id="2" name="Rectangle 1"/>
+          <p:cNvSpPr/>
+          <p:nvPr/>
+        </p:nvSpPr>
+        <p:spPr>
+          <a:xfrm>
+            <a:off x="0" y="0"/>
+            <a:ext cx="12193200" cy="900000"/>
+          </a:xfrm>
+          <a:prstGeom prst="rect">
+            <a:avLst/>
+          </a:prstGeom>
+          <a:solidFill>
+            <a:srgbClr val="1F3864"/>
+          </a:solidFill>
+          <a:ln>
+            <a:noFill/>
+          </a:ln>
+          <a:effectLst/>
+        </p:spPr>
+        <p:style>
+          <a:lnRef idx="1">
+            <a:schemeClr val="accent1"/>
+          </a:lnRef>
+          <a:fillRef idx="3">
+            <a:schemeClr val="accent1"/>
+          </a:fillRef>
+          <a:effectRef idx="2">
+            <a:schemeClr val="accent1"/>
+          </a:effectRef>
+          <a:fontRef idx="minor">
+            <a:schemeClr val="lt1"/>
+          </a:fontRef>
+        </p:style>
+        <p:txBody>
+          <a:bodyPr rtlCol="0" anchor="ctr" lIns="396000"/>
+          <a:lstStyle/>
+          <a:p>
+            <a:pPr algn="l"/>
+            <a:r>
+              <a:rPr sz="2900" b="1">
+                <a:solidFill>
+                  <a:srgbClr val="FFFFFF"/>
+                </a:solidFill>
+                <a:latin typeface="Calibri"/>
+              </a:rPr>
+              <a:t>Cómo se arregla</a:t>
+            </a:r>
+          </a:p>
+        </p:txBody>
+      </p:sp>
+      <p:sp>
+        <p:nvSpPr>
+          <p:cNvPr id="3" name="TextBox 2"/>
+          <p:cNvSpPr txBox="1"/>
+          <p:nvPr/>
+        </p:nvSpPr>
+        <p:spPr>
+          <a:xfrm>
+            <a:off x="396000" y="990000"/>
+            <a:ext cx="11401200" cy="396000"/>
+          </a:xfrm>
+          <a:prstGeom prst="rect">
+            <a:avLst/>
+          </a:prstGeom>
+          <a:noFill/>
+        </p:spPr>
+        <p:txBody>
+          <a:bodyPr wrap="square" anchor="t">
+            <a:spAutoFit/>
+          </a:bodyPr>
+          <a:lstStyle/>
+          <a:p>
+            <a:pPr algn="l">
+              <a:lnSpc>
+                <a:spcPct val="118000"/>
+              </a:lnSpc>
+            </a:pPr>
+            <a:r>
+              <a:rPr sz="1600" b="0">
+                <a:solidFill>
+                  <a:srgbClr val="2E5C9A"/>
+                </a:solidFill>
+                <a:latin typeface="Calibri"/>
+              </a:rPr>
+              <a:t>Las correcciones salen directamente del diagnóstico</a:t>
+            </a:r>
+          </a:p>
+        </p:txBody>
+      </p:sp>
+      <p:sp>
+        <p:nvSpPr>
+          <p:cNvPr id="4" name="TextBox 3"/>
+          <p:cNvSpPr txBox="1"/>
+          <p:nvPr/>
+        </p:nvSpPr>
+        <p:spPr>
+          <a:xfrm>
+            <a:off x="11257200" y="6354001"/>
+            <a:ext cx="648000" cy="324000"/>
+          </a:xfrm>
+          <a:prstGeom prst="rect">
+            <a:avLst/>
+          </a:prstGeom>
+          <a:noFill/>
+        </p:spPr>
+        <p:txBody>
+          <a:bodyPr wrap="square" anchor="t">
+            <a:spAutoFit/>
+          </a:bodyPr>
+          <a:lstStyle/>
+          <a:p>
+            <a:pPr algn="r">
+              <a:lnSpc>
+                <a:spcPct val="118000"/>
+              </a:lnSpc>
+            </a:pPr>
+            <a:r>
+              <a:rPr sz="1200" b="0">
+                <a:solidFill>
+                  <a:srgbClr val="444444"/>
+                </a:solidFill>
+                <a:latin typeface="Calibri"/>
+              </a:rPr>
+              <a:t>13</a:t>
             </a:r>
           </a:p>
         </p:txBody>
@@ -4512,7 +4749,7 @@
                 </a:solidFill>
                 <a:latin typeface="Calibri"/>
               </a:rPr>
-              <a:t>604 temas</a:t>
+              <a:t>20 → 604 temas</a:t>
             </a:r>
           </a:p>
           <a:p>
@@ -4537,7 +4774,7 @@
 </p:sld>
 </file>
 
-<file path=ppt/slides/slide13.xml><?xml version="1.0" encoding="utf-8"?>
+<file path=ppt/slides/slide14.xml><?xml version="1.0" encoding="utf-8"?>
 <p:sld xmlns:a="http://schemas.openxmlformats.org/drawingml/2006/main" xmlns:p="http://schemas.openxmlformats.org/presentationml/2006/main" xmlns:r="http://schemas.openxmlformats.org/officeDocument/2006/relationships">
   <p:cSld>
     <p:bg>
@@ -4589,7 +4826,7 @@
                 </a:solidFill>
                 <a:latin typeface="Calibri"/>
               </a:rPr>
-              <a:t>13</a:t>
+              <a:t>14</a:t>
             </a:r>
           </a:p>
         </p:txBody>
@@ -7985,8 +8222,8 @@
           <p:nvPr/>
         </p:nvGraphicFramePr>
         <p:xfrm>
-          <a:off x="1620000" y="1655999"/>
-          <a:ext cx="9000000" cy="3960000"/>
+          <a:off x="1620000" y="1584000"/>
+          <a:ext cx="9000000" cy="4104000"/>
         </p:xfrm>
         <a:graphic>
           <a:graphicData uri="http://schemas.openxmlformats.org/drawingml/2006/table">
@@ -7999,7 +8236,7 @@
                 <a:gridCol w="1980000"/>
                 <a:gridCol w="1980000"/>
               </a:tblGrid>
-              <a:tr h="440000">
+              <a:tr h="410400">
                 <a:tc>
                   <a:txBody>
                     <a:bodyPr/>
@@ -8007,7 +8244,7 @@
                     <a:p>
                       <a:pPr algn="l"/>
                       <a:r>
-                        <a:rPr sz="1500" b="1">
+                        <a:rPr sz="1400" b="1">
                           <a:solidFill>
                             <a:srgbClr val="FFFFFF"/>
                           </a:solidFill>
@@ -8030,7 +8267,7 @@
                     <a:p>
                       <a:pPr algn="ctr"/>
                       <a:r>
-                        <a:rPr sz="1500" b="1">
+                        <a:rPr sz="1400" b="1">
                           <a:solidFill>
                             <a:srgbClr val="FFFFFF"/>
                           </a:solidFill>
@@ -8053,7 +8290,7 @@
                     <a:p>
                       <a:pPr algn="ctr"/>
                       <a:r>
-                        <a:rPr sz="1500" b="1">
+                        <a:rPr sz="1400" b="1">
                           <a:solidFill>
                             <a:srgbClr val="FFFFFF"/>
                           </a:solidFill>
@@ -8070,7 +8307,7 @@
                   </a:tcPr>
                 </a:tc>
               </a:tr>
-              <a:tr h="440000">
+              <a:tr h="410400">
                 <a:tc>
                   <a:txBody>
                     <a:bodyPr/>
@@ -8078,7 +8315,7 @@
                     <a:p>
                       <a:pPr algn="l"/>
                       <a:r>
-                        <a:rPr sz="1500" b="0">
+                        <a:rPr sz="1400" b="0">
                           <a:solidFill>
                             <a:srgbClr val="444444"/>
                           </a:solidFill>
@@ -8101,7 +8338,7 @@
                     <a:p>
                       <a:pPr algn="ctr"/>
                       <a:r>
-                        <a:rPr sz="1500" b="0">
+                        <a:rPr sz="1400" b="0">
                           <a:solidFill>
                             <a:srgbClr val="444444"/>
                           </a:solidFill>
@@ -8124,7 +8361,7 @@
                     <a:p>
                       <a:pPr algn="ctr"/>
                       <a:r>
-                        <a:rPr sz="1500" b="0">
+                        <a:rPr sz="1400" b="0">
                           <a:solidFill>
                             <a:srgbClr val="444444"/>
                           </a:solidFill>
@@ -8141,7 +8378,7 @@
                   </a:tcPr>
                 </a:tc>
               </a:tr>
-              <a:tr h="440000">
+              <a:tr h="410400">
                 <a:tc>
                   <a:txBody>
                     <a:bodyPr/>
@@ -8149,7 +8386,7 @@
                     <a:p>
                       <a:pPr algn="l"/>
                       <a:r>
-                        <a:rPr sz="1500" b="0">
+                        <a:rPr sz="1400" b="0">
                           <a:solidFill>
                             <a:srgbClr val="444444"/>
                           </a:solidFill>
@@ -8172,7 +8409,7 @@
                     <a:p>
                       <a:pPr algn="ctr"/>
                       <a:r>
-                        <a:rPr sz="1500" b="1">
+                        <a:rPr sz="1400" b="1">
                           <a:solidFill>
                             <a:srgbClr val="1E7A46"/>
                           </a:solidFill>
@@ -8195,7 +8432,7 @@
                     <a:p>
                       <a:pPr algn="ctr"/>
                       <a:r>
-                        <a:rPr sz="1500" b="0">
+                        <a:rPr sz="1400" b="0">
                           <a:solidFill>
                             <a:srgbClr val="444444"/>
                           </a:solidFill>
@@ -8212,7 +8449,7 @@
                   </a:tcPr>
                 </a:tc>
               </a:tr>
-              <a:tr h="440000">
+              <a:tr h="410400">
                 <a:tc>
                   <a:txBody>
                     <a:bodyPr/>
@@ -8220,7 +8457,7 @@
                     <a:p>
                       <a:pPr algn="l"/>
                       <a:r>
-                        <a:rPr sz="1500" b="0">
+                        <a:rPr sz="1400" b="0">
                           <a:solidFill>
                             <a:srgbClr val="444444"/>
                           </a:solidFill>
@@ -8243,7 +8480,7 @@
                     <a:p>
                       <a:pPr algn="ctr"/>
                       <a:r>
-                        <a:rPr sz="1500" b="1">
+                        <a:rPr sz="1400" b="1">
                           <a:solidFill>
                             <a:srgbClr val="1E7A46"/>
                           </a:solidFill>
@@ -8266,7 +8503,7 @@
                     <a:p>
                       <a:pPr algn="ctr"/>
                       <a:r>
-                        <a:rPr sz="1500" b="0">
+                        <a:rPr sz="1400" b="0">
                           <a:solidFill>
                             <a:srgbClr val="444444"/>
                           </a:solidFill>
@@ -8283,7 +8520,7 @@
                   </a:tcPr>
                 </a:tc>
               </a:tr>
-              <a:tr h="440000">
+              <a:tr h="410400">
                 <a:tc>
                   <a:txBody>
                     <a:bodyPr/>
@@ -8291,7 +8528,7 @@
                     <a:p>
                       <a:pPr algn="l"/>
                       <a:r>
-                        <a:rPr sz="1500" b="0">
+                        <a:rPr sz="1400" b="0">
                           <a:solidFill>
                             <a:srgbClr val="444444"/>
                           </a:solidFill>
@@ -8314,7 +8551,7 @@
                     <a:p>
                       <a:pPr algn="ctr"/>
                       <a:r>
-                        <a:rPr sz="1500" b="0">
+                        <a:rPr sz="1400" b="0">
                           <a:solidFill>
                             <a:srgbClr val="444444"/>
                           </a:solidFill>
@@ -8337,7 +8574,7 @@
                     <a:p>
                       <a:pPr algn="ctr"/>
                       <a:r>
-                        <a:rPr sz="1500" b="0">
+                        <a:rPr sz="1400" b="0">
                           <a:solidFill>
                             <a:srgbClr val="444444"/>
                           </a:solidFill>
@@ -8354,7 +8591,7 @@
                   </a:tcPr>
                 </a:tc>
               </a:tr>
-              <a:tr h="440000">
+              <a:tr h="410400">
                 <a:tc>
                   <a:txBody>
                     <a:bodyPr/>
@@ -8362,7 +8599,7 @@
                     <a:p>
                       <a:pPr algn="l"/>
                       <a:r>
-                        <a:rPr sz="1500" b="0">
+                        <a:rPr sz="1400" b="0">
                           <a:solidFill>
                             <a:srgbClr val="444444"/>
                           </a:solidFill>
@@ -8385,7 +8622,7 @@
                     <a:p>
                       <a:pPr algn="ctr"/>
                       <a:r>
-                        <a:rPr sz="1500" b="0">
+                        <a:rPr sz="1400" b="0">
                           <a:solidFill>
                             <a:srgbClr val="444444"/>
                           </a:solidFill>
@@ -8408,7 +8645,7 @@
                     <a:p>
                       <a:pPr algn="ctr"/>
                       <a:r>
-                        <a:rPr sz="1500" b="0">
+                        <a:rPr sz="1400" b="0">
                           <a:solidFill>
                             <a:srgbClr val="444444"/>
                           </a:solidFill>
@@ -8425,7 +8662,7 @@
                   </a:tcPr>
                 </a:tc>
               </a:tr>
-              <a:tr h="440000">
+              <a:tr h="410400">
                 <a:tc>
                   <a:txBody>
                     <a:bodyPr/>
@@ -8433,7 +8670,7 @@
                     <a:p>
                       <a:pPr algn="l"/>
                       <a:r>
-                        <a:rPr sz="1500" b="0">
+                        <a:rPr sz="1400" b="0">
                           <a:solidFill>
                             <a:srgbClr val="444444"/>
                           </a:solidFill>
@@ -8456,7 +8693,7 @@
                     <a:p>
                       <a:pPr algn="ctr"/>
                       <a:r>
-                        <a:rPr sz="1500" b="0">
+                        <a:rPr sz="1400" b="0">
                           <a:solidFill>
                             <a:srgbClr val="444444"/>
                           </a:solidFill>
@@ -8479,7 +8716,7 @@
                     <a:p>
                       <a:pPr algn="ctr"/>
                       <a:r>
-                        <a:rPr sz="1500" b="0">
+                        <a:rPr sz="1400" b="0">
                           <a:solidFill>
                             <a:srgbClr val="444444"/>
                           </a:solidFill>
@@ -8496,7 +8733,7 @@
                   </a:tcPr>
                 </a:tc>
               </a:tr>
-              <a:tr h="440000">
+              <a:tr h="410400">
                 <a:tc>
                   <a:txBody>
                     <a:bodyPr/>
@@ -8504,7 +8741,7 @@
                     <a:p>
                       <a:pPr algn="l"/>
                       <a:r>
-                        <a:rPr sz="1500" b="1">
+                        <a:rPr sz="1400" b="1">
                           <a:solidFill>
                             <a:srgbClr val="C0392B"/>
                           </a:solidFill>
@@ -8527,7 +8764,7 @@
                     <a:p>
                       <a:pPr algn="ctr"/>
                       <a:r>
-                        <a:rPr sz="1500" b="1">
+                        <a:rPr sz="1400" b="1">
                           <a:solidFill>
                             <a:srgbClr val="C0392B"/>
                           </a:solidFill>
@@ -8550,7 +8787,7 @@
                     <a:p>
                       <a:pPr algn="ctr"/>
                       <a:r>
-                        <a:rPr sz="1500" b="1">
+                        <a:rPr sz="1400" b="1">
                           <a:solidFill>
                             <a:srgbClr val="1E7A46"/>
                           </a:solidFill>
@@ -8567,7 +8804,7 @@
                   </a:tcPr>
                 </a:tc>
               </a:tr>
-              <a:tr h="440000">
+              <a:tr h="410400">
                 <a:tc>
                   <a:txBody>
                     <a:bodyPr/>
@@ -8575,13 +8812,13 @@
                     <a:p>
                       <a:pPr algn="l"/>
                       <a:r>
-                        <a:rPr sz="1500" b="0">
+                        <a:rPr sz="1400" b="0">
                           <a:solidFill>
                             <a:srgbClr val="444444"/>
                           </a:solidFill>
                           <a:latin typeface="Calibri"/>
                         </a:rPr>
-                        <a:t>Audio real (5 temas conocidos)</a:t>
+                        <a:t>5 audios generados (tonalidad conocida)</a:t>
                       </a:r>
                     </a:p>
                   </a:txBody>
@@ -8598,7 +8835,7 @@
                     <a:p>
                       <a:pPr algn="ctr"/>
                       <a:r>
-                        <a:rPr sz="1500" b="0">
+                        <a:rPr sz="1400" b="0">
                           <a:solidFill>
                             <a:srgbClr val="444444"/>
                           </a:solidFill>
@@ -8621,7 +8858,7 @@
                     <a:p>
                       <a:pPr algn="ctr"/>
                       <a:r>
-                        <a:rPr sz="1500" b="1">
+                        <a:rPr sz="1400" b="1">
                           <a:solidFill>
                             <a:srgbClr val="1E7A46"/>
                           </a:solidFill>
@@ -8638,6 +8875,77 @@
                   </a:tcPr>
                 </a:tc>
               </a:tr>
+              <a:tr h="410400">
+                <a:tc>
+                  <a:txBody>
+                    <a:bodyPr/>
+                    <a:lstStyle/>
+                    <a:p>
+                      <a:pPr algn="l"/>
+                      <a:r>
+                        <a:rPr sz="1400" b="1">
+                          <a:solidFill>
+                            <a:srgbClr val="C0392B"/>
+                          </a:solidFill>
+                          <a:latin typeface="Calibri"/>
+                        </a:rPr>
+                        <a:t>CANCIONES REALES: GiantSteps (20)</a:t>
+                      </a:r>
+                    </a:p>
+                  </a:txBody>
+                  <a:tcPr anchor="ctr" marL="90000" marT="36000" marB="36000">
+                    <a:solidFill>
+                      <a:srgbClr val="FFFFFF"/>
+                    </a:solidFill>
+                  </a:tcPr>
+                </a:tc>
+                <a:tc>
+                  <a:txBody>
+                    <a:bodyPr/>
+                    <a:lstStyle/>
+                    <a:p>
+                      <a:pPr algn="ctr"/>
+                      <a:r>
+                        <a:rPr sz="1400" b="1">
+                          <a:solidFill>
+                            <a:srgbClr val="C0392B"/>
+                          </a:solidFill>
+                          <a:latin typeface="Calibri"/>
+                        </a:rPr>
+                        <a:t>0,100</a:t>
+                      </a:r>
+                    </a:p>
+                  </a:txBody>
+                  <a:tcPr anchor="ctr" marL="90000" marT="36000" marB="36000">
+                    <a:solidFill>
+                      <a:srgbClr val="FFFFFF"/>
+                    </a:solidFill>
+                  </a:tcPr>
+                </a:tc>
+                <a:tc>
+                  <a:txBody>
+                    <a:bodyPr/>
+                    <a:lstStyle/>
+                    <a:p>
+                      <a:pPr algn="ctr"/>
+                      <a:r>
+                        <a:rPr sz="1400" b="1">
+                          <a:solidFill>
+                            <a:srgbClr val="1E7A46"/>
+                          </a:solidFill>
+                          <a:latin typeface="Calibri"/>
+                        </a:rPr>
+                        <a:t>0,450</a:t>
+                      </a:r>
+                    </a:p>
+                  </a:txBody>
+                  <a:tcPr anchor="ctr" marL="90000" marT="36000" marB="36000">
+                    <a:solidFill>
+                      <a:srgbClr val="FFFFFF"/>
+                    </a:solidFill>
+                  </a:tcPr>
+                </a:tc>
+              </a:tr>
             </a:tbl>
           </a:graphicData>
         </a:graphic>
@@ -8650,7 +8958,7 @@
         </p:nvSpPr>
         <p:spPr>
           <a:xfrm>
-            <a:off x="1620000" y="5832000"/>
+            <a:off x="1620000" y="5868000"/>
             <a:ext cx="9000000" cy="576000"/>
           </a:xfrm>
           <a:prstGeom prst="rect">
@@ -8755,7 +9063,7 @@
                 </a:solidFill>
                 <a:latin typeface="Calibri"/>
               </a:rPr>
-              <a:t>Diagnóstico</a:t>
+              <a:t>Canciones reales: GiantSteps Key</a:t>
             </a:r>
           </a:p>
         </p:txBody>
@@ -8794,7 +9102,7 @@
                 </a:solidFill>
                 <a:latin typeface="Calibri"/>
               </a:rPr>
-              <a:t>¿Qué sigue la red: la tonalidad o la frecuencia absoluta?</a:t>
+              <a:t>20 temas anotados al azar (semilla 7) · solo evaluación · corrida en Colab</a:t>
             </a:r>
           </a:p>
         </p:txBody>
@@ -8838,40 +9146,174 @@
           </a:p>
         </p:txBody>
       </p:sp>
-      <p:pic>
-        <p:nvPicPr>
-          <p:cNvPr id="5" name="Picture 4" descr="diagnostico_octava.png"/>
-          <p:cNvPicPr>
-            <a:picLocks noChangeAspect="1"/>
-          </p:cNvPicPr>
+      <p:sp>
+        <p:nvSpPr>
+          <p:cNvPr id="5" name="Rounded Rectangle 4"/>
+          <p:cNvSpPr/>
           <p:nvPr/>
-        </p:nvPicPr>
-        <p:blipFill>
-          <a:blip r:embed="rId2"/>
-          <a:stretch>
-            <a:fillRect/>
-          </a:stretch>
-        </p:blipFill>
+        </p:nvSpPr>
         <p:spPr>
           <a:xfrm>
-            <a:off x="2496600" y="1368000"/>
-            <a:ext cx="7200000" cy="3600000"/>
+            <a:off x="1080000" y="1655999"/>
+            <a:ext cx="4680000" cy="2015999"/>
           </a:xfrm>
-          <a:prstGeom prst="rect">
+          <a:prstGeom prst="roundRect">
             <a:avLst/>
           </a:prstGeom>
+          <a:solidFill>
+            <a:srgbClr val="FFFFFF"/>
+          </a:solidFill>
+          <a:ln w="13970">
+            <a:solidFill>
+              <a:srgbClr val="C9D4E4"/>
+            </a:solidFill>
+          </a:ln>
+          <a:effectLst/>
         </p:spPr>
-      </p:pic>
-      <p:sp>
-        <p:nvSpPr>
-          <p:cNvPr id="6" name="TextBox 5"/>
+        <p:style>
+          <a:lnRef idx="1">
+            <a:schemeClr val="accent1"/>
+          </a:lnRef>
+          <a:fillRef idx="3">
+            <a:schemeClr val="accent1"/>
+          </a:fillRef>
+          <a:effectRef idx="2">
+            <a:schemeClr val="accent1"/>
+          </a:effectRef>
+          <a:fontRef idx="minor">
+            <a:schemeClr val="lt1"/>
+          </a:fontRef>
+        </p:style>
+        <p:txBody>
+          <a:bodyPr rtlCol="0" anchor="ctr" wrap="square" tIns="125999"/>
+          <a:lstStyle/>
+          <a:p>
+            <a:pPr algn="ctr"/>
+            <a:r>
+              <a:rPr sz="1500">
+                <a:solidFill>
+                  <a:srgbClr val="444444"/>
+                </a:solidFill>
+                <a:latin typeface="Calibri"/>
+              </a:rPr>
+              <a:t>CNN 1D</a:t>
+            </a:r>
+          </a:p>
+          <a:p>
+            <a:pPr algn="ctr"/>
+            <a:r>
+              <a:rPr sz="4000" b="1">
+                <a:solidFill>
+                  <a:srgbClr val="C0392B"/>
+                </a:solidFill>
+                <a:latin typeface="Calibri"/>
+              </a:rPr>
+              <a:t>2 / 20</a:t>
+            </a:r>
+          </a:p>
+          <a:p>
+            <a:pPr algn="ctr"/>
+            <a:r>
+              <a:rPr sz="1250">
+                <a:solidFill>
+                  <a:srgbClr val="444444"/>
+                </a:solidFill>
+                <a:latin typeface="Calibri"/>
+              </a:rPr>
+              <a:t>accuracy 0,10  ·  MIREX 0,13</a:t>
+            </a:r>
+          </a:p>
+        </p:txBody>
+      </p:sp>
+      <p:sp>
+        <p:nvSpPr>
+          <p:cNvPr id="6" name="Rounded Rectangle 5"/>
+          <p:cNvSpPr/>
+          <p:nvPr/>
+        </p:nvSpPr>
+        <p:spPr>
+          <a:xfrm>
+            <a:off x="6443999" y="1655999"/>
+            <a:ext cx="4680000" cy="2015999"/>
+          </a:xfrm>
+          <a:prstGeom prst="roundRect">
+            <a:avLst/>
+          </a:prstGeom>
+          <a:solidFill>
+            <a:srgbClr val="FFFFFF"/>
+          </a:solidFill>
+          <a:ln w="13970">
+            <a:solidFill>
+              <a:srgbClr val="C9D4E4"/>
+            </a:solidFill>
+          </a:ln>
+          <a:effectLst/>
+        </p:spPr>
+        <p:style>
+          <a:lnRef idx="1">
+            <a:schemeClr val="accent1"/>
+          </a:lnRef>
+          <a:fillRef idx="3">
+            <a:schemeClr val="accent1"/>
+          </a:fillRef>
+          <a:effectRef idx="2">
+            <a:schemeClr val="accent1"/>
+          </a:effectRef>
+          <a:fontRef idx="minor">
+            <a:schemeClr val="lt1"/>
+          </a:fontRef>
+        </p:style>
+        <p:txBody>
+          <a:bodyPr rtlCol="0" anchor="ctr" wrap="square" tIns="125999"/>
+          <a:lstStyle/>
+          <a:p>
+            <a:pPr algn="ctr"/>
+            <a:r>
+              <a:rPr sz="1500">
+                <a:solidFill>
+                  <a:srgbClr val="444444"/>
+                </a:solidFill>
+                <a:latin typeface="Calibri"/>
+              </a:rPr>
+              <a:t>BASELINE K-S</a:t>
+            </a:r>
+          </a:p>
+          <a:p>
+            <a:pPr algn="ctr"/>
+            <a:r>
+              <a:rPr sz="4000" b="1">
+                <a:solidFill>
+                  <a:srgbClr val="1E7A46"/>
+                </a:solidFill>
+                <a:latin typeface="Calibri"/>
+              </a:rPr>
+              <a:t>9 / 20</a:t>
+            </a:r>
+          </a:p>
+          <a:p>
+            <a:pPr algn="ctr"/>
+            <a:r>
+              <a:rPr sz="1250">
+                <a:solidFill>
+                  <a:srgbClr val="444444"/>
+                </a:solidFill>
+                <a:latin typeface="Calibri"/>
+              </a:rPr>
+              <a:t>accuracy 0,45  ·  MIREX 0,59</a:t>
+            </a:r>
+          </a:p>
+        </p:txBody>
+      </p:sp>
+      <p:sp>
+        <p:nvSpPr>
+          <p:cNvPr id="7" name="TextBox 6"/>
           <p:cNvSpPr txBox="1"/>
           <p:nvPr/>
         </p:nvSpPr>
         <p:spPr>
           <a:xfrm>
-            <a:off x="720000" y="5184000"/>
-            <a:ext cx="10753200" cy="1296000"/>
+            <a:off x="1080000" y="3960000"/>
+            <a:ext cx="10080000" cy="2160000"/>
           </a:xfrm>
           <a:prstGeom prst="rect">
             <a:avLst/>
@@ -8879,40 +9321,84 @@
           <a:noFill/>
         </p:spPr>
         <p:txBody>
-          <a:bodyPr wrap="square" anchor="t">
+          <a:bodyPr wrap="square">
             <a:spAutoFit/>
           </a:bodyPr>
           <a:lstStyle/>
           <a:p>
-            <a:pPr algn="ctr">
-              <a:lnSpc>
-                <a:spcPct val="130000"/>
-              </a:lnSpc>
-            </a:pPr>
-            <a:r>
-              <a:rPr sz="2000" b="1">
-                <a:solidFill>
-                  <a:srgbClr val="C0392B"/>
-                </a:solidFill>
-                <a:latin typeface="Calibri"/>
-              </a:rPr>
-              <a:t>Al desplazar el audio UN SEMITONO:</a:t>
-            </a:r>
-          </a:p>
-          <a:p>
-            <a:pPr algn="ctr">
-              <a:lnSpc>
-                <a:spcPct val="130000"/>
-              </a:lnSpc>
-            </a:pPr>
-            <a:r>
-              <a:rPr sz="2000" b="1">
-                <a:solidFill>
-                  <a:srgbClr val="C0392B"/>
-                </a:solidFill>
-                <a:latin typeface="Calibri"/>
-              </a:rPr>
-              <a:t>predice la etiqueta transpuesta el 91,7 %  ·  acierta la correcta el 0 %</a:t>
+            <a:pPr>
+              <a:lnSpc>
+                <a:spcPct val="115000"/>
+              </a:lnSpc>
+              <a:spcAft>
+                <a:spcPts val="800"/>
+              </a:spcAft>
+            </a:pPr>
+            <a:r>
+              <a:rPr sz="1700" b="1">
+                <a:solidFill>
+                  <a:srgbClr val="1F3864"/>
+                </a:solidFill>
+                <a:latin typeface="Calibri"/>
+              </a:rPr>
+              <a:t>•  La red responde "A maj" en 11 de los 20 temas, sin importar la canción.</a:t>
+            </a:r>
+          </a:p>
+          <a:p>
+            <a:pPr>
+              <a:lnSpc>
+                <a:spcPct val="115000"/>
+              </a:lnSpc>
+              <a:spcAft>
+                <a:spcPts val="800"/>
+              </a:spcAft>
+            </a:pPr>
+            <a:r>
+              <a:rPr sz="1700" b="0">
+                <a:solidFill>
+                  <a:srgbClr val="444444"/>
+                </a:solidFill>
+                <a:latin typeface="Calibri"/>
+              </a:rPr>
+              <a:t>•  Usa solo 4 de las 24 clases. Sus 2 aciertos son temas que estaban en A maj.</a:t>
+            </a:r>
+          </a:p>
+          <a:p>
+            <a:pPr>
+              <a:lnSpc>
+                <a:spcPct val="115000"/>
+              </a:lnSpc>
+              <a:spcAft>
+                <a:spcPts val="800"/>
+              </a:spcAft>
+            </a:pPr>
+            <a:r>
+              <a:rPr sz="1700" b="1">
+                <a:solidFill>
+                  <a:srgbClr val="1F3864"/>
+                </a:solidFill>
+                <a:latin typeface="Calibri"/>
+              </a:rPr>
+              <a:t>•  Es el mismo colapso a pocos atractores que aparece al transponer una octava.</a:t>
+            </a:r>
+          </a:p>
+          <a:p>
+            <a:pPr>
+              <a:lnSpc>
+                <a:spcPct val="115000"/>
+              </a:lnSpc>
+              <a:spcAft>
+                <a:spcPts val="800"/>
+              </a:spcAft>
+            </a:pPr>
+            <a:r>
+              <a:rPr sz="1700" b="0">
+                <a:solidFill>
+                  <a:srgbClr val="444444"/>
+                </a:solidFill>
+                <a:latin typeface="Calibri"/>
+              </a:rPr>
+              <a:t>•  K-S acierta la tónica en 14 de 20; casi todos sus errores son de quinta, relativa o modo.</a:t>
             </a:r>
           </a:p>
         </p:txBody>

</xml_diff>